<commit_message>
Fix APK Release Build: Added TFLite Proguard rules and increased Gradle JVM memory
</commit_message>
<xml_diff>
--- a/KrushikaDhara_Master_HoD_Pitch.pptx
+++ b/KrushikaDhara_Master_HoD_Pitch.pptx
@@ -1,23 +1,23 @@
 
 <file path=ppt/presentation.xml><?xml version="1.0" encoding="utf-8"?>
-<p:presentation xmlns:a="http://schemas.openxmlformats.org/drawingml/2006/main" xmlns:r="http://schemas.openxmlformats.org/officeDocument/2006/relationships" xmlns:p="http://schemas.openxmlformats.org/presentationml/2006/main" saveSubsetFonts="1" autoCompressPictures="0">
+<p:presentation xmlns:a="http://schemas.openxmlformats.org/drawingml/2006/main" xmlns:r="http://schemas.openxmlformats.org/officeDocument/2006/relationships" xmlns:p="http://schemas.openxmlformats.org/presentationml/2006/main" autoCompressPictures="0">
   <p:sldMasterIdLst>
     <p:sldMasterId id="2147483648" r:id="rId1"/>
   </p:sldMasterIdLst>
   <p:sldIdLst>
-    <p:sldId id="256" r:id="rId7"/>
-    <p:sldId id="257" r:id="rId8"/>
-    <p:sldId id="258" r:id="rId9"/>
-    <p:sldId id="259" r:id="rId10"/>
-    <p:sldId id="260" r:id="rId11"/>
-    <p:sldId id="261" r:id="rId12"/>
-    <p:sldId id="262" r:id="rId13"/>
-    <p:sldId id="263" r:id="rId14"/>
-    <p:sldId id="264" r:id="rId15"/>
-    <p:sldId id="265" r:id="rId16"/>
-    <p:sldId id="266" r:id="rId17"/>
-    <p:sldId id="267" r:id="rId18"/>
-    <p:sldId id="268" r:id="rId19"/>
+    <p:sldId id="256" r:id="rId3"/>
+    <p:sldId id="257" r:id="rId4"/>
+    <p:sldId id="258" r:id="rId5"/>
+    <p:sldId id="259" r:id="rId6"/>
+    <p:sldId id="260" r:id="rId7"/>
+    <p:sldId id="261" r:id="rId8"/>
+    <p:sldId id="262" r:id="rId9"/>
+    <p:sldId id="263" r:id="rId10"/>
+    <p:sldId id="264" r:id="rId11"/>
+    <p:sldId id="265" r:id="rId12"/>
+    <p:sldId id="266" r:id="rId13"/>
+    <p:sldId id="267" r:id="rId14"/>
+    <p:sldId id="268" r:id="rId15"/>
   </p:sldIdLst>
   <p:sldSz cx="9144000" cy="6858000" type="screen4x3"/>
   <p:notesSz cx="6858000" cy="9144000"/>
@@ -116,6 +116,22 @@
       </a:defRPr>
     </a:lvl9pPr>
   </p:defaultTextStyle>
+  <p:extLst>
+    <p:ext uri="{EFAFB233-063F-42B5-8137-9DF3F51BA10A}">
+      <p15:sldGuideLst xmlns:p15="http://schemas.microsoft.com/office/powerpoint/2012/main">
+        <p15:guide id="1" orient="horz" pos="2160" userDrawn="1">
+          <p15:clr>
+            <a:srgbClr val="A4A3A4"/>
+          </p15:clr>
+        </p15:guide>
+        <p15:guide id="2" pos="2880" userDrawn="1">
+          <p15:clr>
+            <a:srgbClr val="A4A3A4"/>
+          </p15:clr>
+        </p15:guide>
+      </p15:sldGuideLst>
+    </p:ext>
+  </p:extLst>
 </p:presentation>
 </file>
 
@@ -300,7 +316,6 @@
           <a:p>
             <a:fld id="{5BCAD085-E8A6-8845-BD4E-CB4CCA059FC4}" type="datetimeFigureOut">
               <a:rPr lang="en-US" smtClean="0"/>
-              <a:t>1/27/13</a:t>
             </a:fld>
             <a:endParaRPr lang="en-US"/>
           </a:p>
@@ -342,18 +357,12 @@
           <a:p>
             <a:fld id="{C1FF6DA9-008F-8B48-92A6-B652298478BF}" type="slidenum">
               <a:rPr lang="en-US" smtClean="0"/>
-              <a:t>‹#›</a:t>
             </a:fld>
             <a:endParaRPr lang="en-US"/>
           </a:p>
         </p:txBody>
       </p:sp>
     </p:spTree>
-    <p:extLst>
-      <p:ext uri="{BB962C8B-B14F-4D97-AF65-F5344CB8AC3E}">
-        <p14:creationId xmlns:p14="http://schemas.microsoft.com/office/powerpoint/2010/main" val="3168075583"/>
-      </p:ext>
-    </p:extLst>
   </p:cSld>
   <p:clrMapOvr>
     <a:masterClrMapping/>
@@ -421,6 +430,7 @@
               <a:rPr lang="en-US" smtClean="0"/>
               <a:t>Click to edit Master text styles</a:t>
             </a:r>
+            <a:endParaRPr lang="en-US" smtClean="0"/>
           </a:p>
           <a:p>
             <a:pPr lvl="1"/>
@@ -428,6 +438,7 @@
               <a:rPr lang="en-US" smtClean="0"/>
               <a:t>Second level</a:t>
             </a:r>
+            <a:endParaRPr lang="en-US" smtClean="0"/>
           </a:p>
           <a:p>
             <a:pPr lvl="2"/>
@@ -435,6 +446,7 @@
               <a:rPr lang="en-US" smtClean="0"/>
               <a:t>Third level</a:t>
             </a:r>
+            <a:endParaRPr lang="en-US" smtClean="0"/>
           </a:p>
           <a:p>
             <a:pPr lvl="3"/>
@@ -442,6 +454,7 @@
               <a:rPr lang="en-US" smtClean="0"/>
               <a:t>Fourth level</a:t>
             </a:r>
+            <a:endParaRPr lang="en-US" smtClean="0"/>
           </a:p>
           <a:p>
             <a:pPr lvl="4"/>
@@ -470,7 +483,6 @@
           <a:p>
             <a:fld id="{5BCAD085-E8A6-8845-BD4E-CB4CCA059FC4}" type="datetimeFigureOut">
               <a:rPr lang="en-US" smtClean="0"/>
-              <a:t>1/27/13</a:t>
             </a:fld>
             <a:endParaRPr lang="en-US"/>
           </a:p>
@@ -512,18 +524,12 @@
           <a:p>
             <a:fld id="{C1FF6DA9-008F-8B48-92A6-B652298478BF}" type="slidenum">
               <a:rPr lang="en-US" smtClean="0"/>
-              <a:t>‹#›</a:t>
             </a:fld>
             <a:endParaRPr lang="en-US"/>
           </a:p>
         </p:txBody>
       </p:sp>
     </p:spTree>
-    <p:extLst>
-      <p:ext uri="{BB962C8B-B14F-4D97-AF65-F5344CB8AC3E}">
-        <p14:creationId xmlns:p14="http://schemas.microsoft.com/office/powerpoint/2010/main" val="2910927964"/>
-      </p:ext>
-    </p:extLst>
   </p:cSld>
   <p:clrMapOvr>
     <a:masterClrMapping/>
@@ -601,6 +607,7 @@
               <a:rPr lang="en-US" smtClean="0"/>
               <a:t>Click to edit Master text styles</a:t>
             </a:r>
+            <a:endParaRPr lang="en-US" smtClean="0"/>
           </a:p>
           <a:p>
             <a:pPr lvl="1"/>
@@ -608,6 +615,7 @@
               <a:rPr lang="en-US" smtClean="0"/>
               <a:t>Second level</a:t>
             </a:r>
+            <a:endParaRPr lang="en-US" smtClean="0"/>
           </a:p>
           <a:p>
             <a:pPr lvl="2"/>
@@ -615,6 +623,7 @@
               <a:rPr lang="en-US" smtClean="0"/>
               <a:t>Third level</a:t>
             </a:r>
+            <a:endParaRPr lang="en-US" smtClean="0"/>
           </a:p>
           <a:p>
             <a:pPr lvl="3"/>
@@ -622,6 +631,7 @@
               <a:rPr lang="en-US" smtClean="0"/>
               <a:t>Fourth level</a:t>
             </a:r>
+            <a:endParaRPr lang="en-US" smtClean="0"/>
           </a:p>
           <a:p>
             <a:pPr lvl="4"/>
@@ -650,7 +660,6 @@
           <a:p>
             <a:fld id="{5BCAD085-E8A6-8845-BD4E-CB4CCA059FC4}" type="datetimeFigureOut">
               <a:rPr lang="en-US" smtClean="0"/>
-              <a:t>1/27/13</a:t>
             </a:fld>
             <a:endParaRPr lang="en-US"/>
           </a:p>
@@ -692,18 +701,12 @@
           <a:p>
             <a:fld id="{C1FF6DA9-008F-8B48-92A6-B652298478BF}" type="slidenum">
               <a:rPr lang="en-US" smtClean="0"/>
-              <a:t>‹#›</a:t>
             </a:fld>
             <a:endParaRPr lang="en-US"/>
           </a:p>
         </p:txBody>
       </p:sp>
     </p:spTree>
-    <p:extLst>
-      <p:ext uri="{BB962C8B-B14F-4D97-AF65-F5344CB8AC3E}">
-        <p14:creationId xmlns:p14="http://schemas.microsoft.com/office/powerpoint/2010/main" val="3612223792"/>
-      </p:ext>
-    </p:extLst>
   </p:cSld>
   <p:clrMapOvr>
     <a:masterClrMapping/>
@@ -771,6 +774,7 @@
               <a:rPr lang="en-US" smtClean="0"/>
               <a:t>Click to edit Master text styles</a:t>
             </a:r>
+            <a:endParaRPr lang="en-US" smtClean="0"/>
           </a:p>
           <a:p>
             <a:pPr lvl="1"/>
@@ -778,6 +782,7 @@
               <a:rPr lang="en-US" smtClean="0"/>
               <a:t>Second level</a:t>
             </a:r>
+            <a:endParaRPr lang="en-US" smtClean="0"/>
           </a:p>
           <a:p>
             <a:pPr lvl="2"/>
@@ -785,6 +790,7 @@
               <a:rPr lang="en-US" smtClean="0"/>
               <a:t>Third level</a:t>
             </a:r>
+            <a:endParaRPr lang="en-US" smtClean="0"/>
           </a:p>
           <a:p>
             <a:pPr lvl="3"/>
@@ -792,6 +798,7 @@
               <a:rPr lang="en-US" smtClean="0"/>
               <a:t>Fourth level</a:t>
             </a:r>
+            <a:endParaRPr lang="en-US" smtClean="0"/>
           </a:p>
           <a:p>
             <a:pPr lvl="4"/>
@@ -820,7 +827,6 @@
           <a:p>
             <a:fld id="{5BCAD085-E8A6-8845-BD4E-CB4CCA059FC4}" type="datetimeFigureOut">
               <a:rPr lang="en-US" smtClean="0"/>
-              <a:t>1/27/13</a:t>
             </a:fld>
             <a:endParaRPr lang="en-US"/>
           </a:p>
@@ -862,18 +868,12 @@
           <a:p>
             <a:fld id="{C1FF6DA9-008F-8B48-92A6-B652298478BF}" type="slidenum">
               <a:rPr lang="en-US" smtClean="0"/>
-              <a:t>‹#›</a:t>
             </a:fld>
             <a:endParaRPr lang="en-US"/>
           </a:p>
         </p:txBody>
       </p:sp>
     </p:spTree>
-    <p:extLst>
-      <p:ext uri="{BB962C8B-B14F-4D97-AF65-F5344CB8AC3E}">
-        <p14:creationId xmlns:p14="http://schemas.microsoft.com/office/powerpoint/2010/main" val="2614314258"/>
-      </p:ext>
-    </p:extLst>
   </p:cSld>
   <p:clrMapOvr>
     <a:masterClrMapping/>
@@ -1046,6 +1046,7 @@
               <a:rPr lang="en-US" smtClean="0"/>
               <a:t>Click to edit Master text styles</a:t>
             </a:r>
+            <a:endParaRPr lang="en-US" smtClean="0"/>
           </a:p>
         </p:txBody>
       </p:sp>
@@ -1066,7 +1067,6 @@
           <a:p>
             <a:fld id="{5BCAD085-E8A6-8845-BD4E-CB4CCA059FC4}" type="datetimeFigureOut">
               <a:rPr lang="en-US" smtClean="0"/>
-              <a:t>1/27/13</a:t>
             </a:fld>
             <a:endParaRPr lang="en-US"/>
           </a:p>
@@ -1108,18 +1108,12 @@
           <a:p>
             <a:fld id="{C1FF6DA9-008F-8B48-92A6-B652298478BF}" type="slidenum">
               <a:rPr lang="en-US" smtClean="0"/>
-              <a:t>‹#›</a:t>
             </a:fld>
             <a:endParaRPr lang="en-US"/>
           </a:p>
         </p:txBody>
       </p:sp>
     </p:spTree>
-    <p:extLst>
-      <p:ext uri="{BB962C8B-B14F-4D97-AF65-F5344CB8AC3E}">
-        <p14:creationId xmlns:p14="http://schemas.microsoft.com/office/powerpoint/2010/main" val="960648375"/>
-      </p:ext>
-    </p:extLst>
   </p:cSld>
   <p:clrMapOvr>
     <a:masterClrMapping/>
@@ -1220,6 +1214,7 @@
               <a:rPr lang="en-US" smtClean="0"/>
               <a:t>Click to edit Master text styles</a:t>
             </a:r>
+            <a:endParaRPr lang="en-US" smtClean="0"/>
           </a:p>
           <a:p>
             <a:pPr lvl="1"/>
@@ -1227,6 +1222,7 @@
               <a:rPr lang="en-US" smtClean="0"/>
               <a:t>Second level</a:t>
             </a:r>
+            <a:endParaRPr lang="en-US" smtClean="0"/>
           </a:p>
           <a:p>
             <a:pPr lvl="2"/>
@@ -1234,6 +1230,7 @@
               <a:rPr lang="en-US" smtClean="0"/>
               <a:t>Third level</a:t>
             </a:r>
+            <a:endParaRPr lang="en-US" smtClean="0"/>
           </a:p>
           <a:p>
             <a:pPr lvl="3"/>
@@ -1241,6 +1238,7 @@
               <a:rPr lang="en-US" smtClean="0"/>
               <a:t>Fourth level</a:t>
             </a:r>
+            <a:endParaRPr lang="en-US" smtClean="0"/>
           </a:p>
           <a:p>
             <a:pPr lvl="4"/>
@@ -1305,6 +1303,7 @@
               <a:rPr lang="en-US" smtClean="0"/>
               <a:t>Click to edit Master text styles</a:t>
             </a:r>
+            <a:endParaRPr lang="en-US" smtClean="0"/>
           </a:p>
           <a:p>
             <a:pPr lvl="1"/>
@@ -1312,6 +1311,7 @@
               <a:rPr lang="en-US" smtClean="0"/>
               <a:t>Second level</a:t>
             </a:r>
+            <a:endParaRPr lang="en-US" smtClean="0"/>
           </a:p>
           <a:p>
             <a:pPr lvl="2"/>
@@ -1319,6 +1319,7 @@
               <a:rPr lang="en-US" smtClean="0"/>
               <a:t>Third level</a:t>
             </a:r>
+            <a:endParaRPr lang="en-US" smtClean="0"/>
           </a:p>
           <a:p>
             <a:pPr lvl="3"/>
@@ -1326,6 +1327,7 @@
               <a:rPr lang="en-US" smtClean="0"/>
               <a:t>Fourth level</a:t>
             </a:r>
+            <a:endParaRPr lang="en-US" smtClean="0"/>
           </a:p>
           <a:p>
             <a:pPr lvl="4"/>
@@ -1354,7 +1356,6 @@
           <a:p>
             <a:fld id="{5BCAD085-E8A6-8845-BD4E-CB4CCA059FC4}" type="datetimeFigureOut">
               <a:rPr lang="en-US" smtClean="0"/>
-              <a:t>1/27/13</a:t>
             </a:fld>
             <a:endParaRPr lang="en-US"/>
           </a:p>
@@ -1396,18 +1397,12 @@
           <a:p>
             <a:fld id="{C1FF6DA9-008F-8B48-92A6-B652298478BF}" type="slidenum">
               <a:rPr lang="en-US" smtClean="0"/>
-              <a:t>‹#›</a:t>
             </a:fld>
             <a:endParaRPr lang="en-US"/>
           </a:p>
         </p:txBody>
       </p:sp>
     </p:spTree>
-    <p:extLst>
-      <p:ext uri="{BB962C8B-B14F-4D97-AF65-F5344CB8AC3E}">
-        <p14:creationId xmlns:p14="http://schemas.microsoft.com/office/powerpoint/2010/main" val="2782244947"/>
-      </p:ext>
-    </p:extLst>
   </p:cSld>
   <p:clrMapOvr>
     <a:masterClrMapping/>
@@ -1521,6 +1516,7 @@
               <a:rPr lang="en-US" smtClean="0"/>
               <a:t>Click to edit Master text styles</a:t>
             </a:r>
+            <a:endParaRPr lang="en-US" smtClean="0"/>
           </a:p>
         </p:txBody>
       </p:sp>
@@ -1577,6 +1573,7 @@
               <a:rPr lang="en-US" smtClean="0"/>
               <a:t>Click to edit Master text styles</a:t>
             </a:r>
+            <a:endParaRPr lang="en-US" smtClean="0"/>
           </a:p>
           <a:p>
             <a:pPr lvl="1"/>
@@ -1584,6 +1581,7 @@
               <a:rPr lang="en-US" smtClean="0"/>
               <a:t>Second level</a:t>
             </a:r>
+            <a:endParaRPr lang="en-US" smtClean="0"/>
           </a:p>
           <a:p>
             <a:pPr lvl="2"/>
@@ -1591,6 +1589,7 @@
               <a:rPr lang="en-US" smtClean="0"/>
               <a:t>Third level</a:t>
             </a:r>
+            <a:endParaRPr lang="en-US" smtClean="0"/>
           </a:p>
           <a:p>
             <a:pPr lvl="3"/>
@@ -1598,6 +1597,7 @@
               <a:rPr lang="en-US" smtClean="0"/>
               <a:t>Fourth level</a:t>
             </a:r>
+            <a:endParaRPr lang="en-US" smtClean="0"/>
           </a:p>
           <a:p>
             <a:pPr lvl="4"/>
@@ -1671,6 +1671,7 @@
               <a:rPr lang="en-US" smtClean="0"/>
               <a:t>Click to edit Master text styles</a:t>
             </a:r>
+            <a:endParaRPr lang="en-US" smtClean="0"/>
           </a:p>
         </p:txBody>
       </p:sp>
@@ -1727,6 +1728,7 @@
               <a:rPr lang="en-US" smtClean="0"/>
               <a:t>Click to edit Master text styles</a:t>
             </a:r>
+            <a:endParaRPr lang="en-US" smtClean="0"/>
           </a:p>
           <a:p>
             <a:pPr lvl="1"/>
@@ -1734,6 +1736,7 @@
               <a:rPr lang="en-US" smtClean="0"/>
               <a:t>Second level</a:t>
             </a:r>
+            <a:endParaRPr lang="en-US" smtClean="0"/>
           </a:p>
           <a:p>
             <a:pPr lvl="2"/>
@@ -1741,6 +1744,7 @@
               <a:rPr lang="en-US" smtClean="0"/>
               <a:t>Third level</a:t>
             </a:r>
+            <a:endParaRPr lang="en-US" smtClean="0"/>
           </a:p>
           <a:p>
             <a:pPr lvl="3"/>
@@ -1748,6 +1752,7 @@
               <a:rPr lang="en-US" smtClean="0"/>
               <a:t>Fourth level</a:t>
             </a:r>
+            <a:endParaRPr lang="en-US" smtClean="0"/>
           </a:p>
           <a:p>
             <a:pPr lvl="4"/>
@@ -1776,7 +1781,6 @@
           <a:p>
             <a:fld id="{5BCAD085-E8A6-8845-BD4E-CB4CCA059FC4}" type="datetimeFigureOut">
               <a:rPr lang="en-US" smtClean="0"/>
-              <a:t>1/27/13</a:t>
             </a:fld>
             <a:endParaRPr lang="en-US"/>
           </a:p>
@@ -1818,18 +1822,12 @@
           <a:p>
             <a:fld id="{C1FF6DA9-008F-8B48-92A6-B652298478BF}" type="slidenum">
               <a:rPr lang="en-US" smtClean="0"/>
-              <a:t>‹#›</a:t>
             </a:fld>
             <a:endParaRPr lang="en-US"/>
           </a:p>
         </p:txBody>
       </p:sp>
     </p:spTree>
-    <p:extLst>
-      <p:ext uri="{BB962C8B-B14F-4D97-AF65-F5344CB8AC3E}">
-        <p14:creationId xmlns:p14="http://schemas.microsoft.com/office/powerpoint/2010/main" val="990158736"/>
-      </p:ext>
-    </p:extLst>
   </p:cSld>
   <p:clrMapOvr>
     <a:masterClrMapping/>
@@ -1894,7 +1892,6 @@
           <a:p>
             <a:fld id="{5BCAD085-E8A6-8845-BD4E-CB4CCA059FC4}" type="datetimeFigureOut">
               <a:rPr lang="en-US" smtClean="0"/>
-              <a:t>1/27/13</a:t>
             </a:fld>
             <a:endParaRPr lang="en-US"/>
           </a:p>
@@ -1936,18 +1933,12 @@
           <a:p>
             <a:fld id="{C1FF6DA9-008F-8B48-92A6-B652298478BF}" type="slidenum">
               <a:rPr lang="en-US" smtClean="0"/>
-              <a:t>‹#›</a:t>
             </a:fld>
             <a:endParaRPr lang="en-US"/>
           </a:p>
         </p:txBody>
       </p:sp>
     </p:spTree>
-    <p:extLst>
-      <p:ext uri="{BB962C8B-B14F-4D97-AF65-F5344CB8AC3E}">
-        <p14:creationId xmlns:p14="http://schemas.microsoft.com/office/powerpoint/2010/main" val="727027711"/>
-      </p:ext>
-    </p:extLst>
   </p:cSld>
   <p:clrMapOvr>
     <a:masterClrMapping/>
@@ -1989,7 +1980,6 @@
           <a:p>
             <a:fld id="{5BCAD085-E8A6-8845-BD4E-CB4CCA059FC4}" type="datetimeFigureOut">
               <a:rPr lang="en-US" smtClean="0"/>
-              <a:t>1/27/13</a:t>
             </a:fld>
             <a:endParaRPr lang="en-US"/>
           </a:p>
@@ -2031,18 +2021,12 @@
           <a:p>
             <a:fld id="{C1FF6DA9-008F-8B48-92A6-B652298478BF}" type="slidenum">
               <a:rPr lang="en-US" smtClean="0"/>
-              <a:t>‹#›</a:t>
             </a:fld>
             <a:endParaRPr lang="en-US"/>
           </a:p>
         </p:txBody>
       </p:sp>
     </p:spTree>
-    <p:extLst>
-      <p:ext uri="{BB962C8B-B14F-4D97-AF65-F5344CB8AC3E}">
-        <p14:creationId xmlns:p14="http://schemas.microsoft.com/office/powerpoint/2010/main" val="1212999818"/>
-      </p:ext>
-    </p:extLst>
   </p:cSld>
   <p:clrMapOvr>
     <a:masterClrMapping/>
@@ -2152,6 +2136,7 @@
               <a:rPr lang="en-US" smtClean="0"/>
               <a:t>Click to edit Master text styles</a:t>
             </a:r>
+            <a:endParaRPr lang="en-US" smtClean="0"/>
           </a:p>
           <a:p>
             <a:pPr lvl="1"/>
@@ -2159,6 +2144,7 @@
               <a:rPr lang="en-US" smtClean="0"/>
               <a:t>Second level</a:t>
             </a:r>
+            <a:endParaRPr lang="en-US" smtClean="0"/>
           </a:p>
           <a:p>
             <a:pPr lvl="2"/>
@@ -2166,6 +2152,7 @@
               <a:rPr lang="en-US" smtClean="0"/>
               <a:t>Third level</a:t>
             </a:r>
+            <a:endParaRPr lang="en-US" smtClean="0"/>
           </a:p>
           <a:p>
             <a:pPr lvl="3"/>
@@ -2173,6 +2160,7 @@
               <a:rPr lang="en-US" smtClean="0"/>
               <a:t>Fourth level</a:t>
             </a:r>
+            <a:endParaRPr lang="en-US" smtClean="0"/>
           </a:p>
           <a:p>
             <a:pPr lvl="4"/>
@@ -2246,6 +2234,7 @@
               <a:rPr lang="en-US" smtClean="0"/>
               <a:t>Click to edit Master text styles</a:t>
             </a:r>
+            <a:endParaRPr lang="en-US" smtClean="0"/>
           </a:p>
         </p:txBody>
       </p:sp>
@@ -2266,7 +2255,6 @@
           <a:p>
             <a:fld id="{5BCAD085-E8A6-8845-BD4E-CB4CCA059FC4}" type="datetimeFigureOut">
               <a:rPr lang="en-US" smtClean="0"/>
-              <a:t>1/27/13</a:t>
             </a:fld>
             <a:endParaRPr lang="en-US"/>
           </a:p>
@@ -2308,18 +2296,12 @@
           <a:p>
             <a:fld id="{C1FF6DA9-008F-8B48-92A6-B652298478BF}" type="slidenum">
               <a:rPr lang="en-US" smtClean="0"/>
-              <a:t>‹#›</a:t>
             </a:fld>
             <a:endParaRPr lang="en-US"/>
           </a:p>
         </p:txBody>
       </p:sp>
     </p:spTree>
-    <p:extLst>
-      <p:ext uri="{BB962C8B-B14F-4D97-AF65-F5344CB8AC3E}">
-        <p14:creationId xmlns:p14="http://schemas.microsoft.com/office/powerpoint/2010/main" val="1840726560"/>
-      </p:ext>
-    </p:extLst>
   </p:cSld>
   <p:clrMapOvr>
     <a:masterClrMapping/>
@@ -2499,6 +2481,7 @@
               <a:rPr lang="en-US" smtClean="0"/>
               <a:t>Click to edit Master text styles</a:t>
             </a:r>
+            <a:endParaRPr lang="en-US" smtClean="0"/>
           </a:p>
         </p:txBody>
       </p:sp>
@@ -2519,7 +2502,6 @@
           <a:p>
             <a:fld id="{5BCAD085-E8A6-8845-BD4E-CB4CCA059FC4}" type="datetimeFigureOut">
               <a:rPr lang="en-US" smtClean="0"/>
-              <a:t>1/27/13</a:t>
             </a:fld>
             <a:endParaRPr lang="en-US"/>
           </a:p>
@@ -2561,18 +2543,12 @@
           <a:p>
             <a:fld id="{C1FF6DA9-008F-8B48-92A6-B652298478BF}" type="slidenum">
               <a:rPr lang="en-US" smtClean="0"/>
-              <a:t>‹#›</a:t>
             </a:fld>
             <a:endParaRPr lang="en-US"/>
           </a:p>
         </p:txBody>
       </p:sp>
     </p:spTree>
-    <p:extLst>
-      <p:ext uri="{BB962C8B-B14F-4D97-AF65-F5344CB8AC3E}">
-        <p14:creationId xmlns:p14="http://schemas.microsoft.com/office/powerpoint/2010/main" val="3889236939"/>
-      </p:ext>
-    </p:extLst>
   </p:cSld>
   <p:clrMapOvr>
     <a:masterClrMapping/>
@@ -2665,6 +2641,7 @@
               <a:rPr lang="en-US" smtClean="0"/>
               <a:t>Click to edit Master text styles</a:t>
             </a:r>
+            <a:endParaRPr lang="en-US" smtClean="0"/>
           </a:p>
           <a:p>
             <a:pPr lvl="1"/>
@@ -2672,6 +2649,7 @@
               <a:rPr lang="en-US" smtClean="0"/>
               <a:t>Second level</a:t>
             </a:r>
+            <a:endParaRPr lang="en-US" smtClean="0"/>
           </a:p>
           <a:p>
             <a:pPr lvl="2"/>
@@ -2679,6 +2657,7 @@
               <a:rPr lang="en-US" smtClean="0"/>
               <a:t>Third level</a:t>
             </a:r>
+            <a:endParaRPr lang="en-US" smtClean="0"/>
           </a:p>
           <a:p>
             <a:pPr lvl="3"/>
@@ -2686,6 +2665,7 @@
               <a:rPr lang="en-US" smtClean="0"/>
               <a:t>Fourth level</a:t>
             </a:r>
+            <a:endParaRPr lang="en-US" smtClean="0"/>
           </a:p>
           <a:p>
             <a:pPr lvl="4"/>
@@ -2732,7 +2712,6 @@
           <a:p>
             <a:fld id="{5BCAD085-E8A6-8845-BD4E-CB4CCA059FC4}" type="datetimeFigureOut">
               <a:rPr lang="en-US" smtClean="0"/>
-              <a:t>1/27/13</a:t>
             </a:fld>
             <a:endParaRPr lang="en-US"/>
           </a:p>
@@ -2810,18 +2789,12 @@
           <a:p>
             <a:fld id="{C1FF6DA9-008F-8B48-92A6-B652298478BF}" type="slidenum">
               <a:rPr lang="en-US" smtClean="0"/>
-              <a:t>‹#›</a:t>
             </a:fld>
             <a:endParaRPr lang="en-US"/>
           </a:p>
         </p:txBody>
       </p:sp>
     </p:spTree>
-    <p:extLst>
-      <p:ext uri="{BB962C8B-B14F-4D97-AF65-F5344CB8AC3E}">
-        <p14:creationId xmlns:p14="http://schemas.microsoft.com/office/powerpoint/2010/main" val="2209977519"/>
-      </p:ext>
-    </p:extLst>
   </p:cSld>
   <p:clrMap bg1="lt1" tx1="dk1" bg2="lt2" tx2="dk2" accent1="accent1" accent2="accent2" accent3="accent3" accent4="accent4" accent5="accent5" accent6="accent6" hlink="hlink" folHlink="folHlink"/>
   <p:sldLayoutIdLst>
@@ -2859,7 +2832,7 @@
         <a:spcBef>
           <a:spcPct val="20000"/>
         </a:spcBef>
-        <a:buFont typeface="Arial"/>
+        <a:buFont typeface="Arial" panose="020B0604020202020204"/>
         <a:buChar char="•"/>
         <a:defRPr sz="3200" kern="1200">
           <a:solidFill>
@@ -2874,7 +2847,7 @@
         <a:spcBef>
           <a:spcPct val="20000"/>
         </a:spcBef>
-        <a:buFont typeface="Arial"/>
+        <a:buFont typeface="Arial" panose="020B0604020202020204"/>
         <a:buChar char="–"/>
         <a:defRPr sz="2800" kern="1200">
           <a:solidFill>
@@ -2889,7 +2862,7 @@
         <a:spcBef>
           <a:spcPct val="20000"/>
         </a:spcBef>
-        <a:buFont typeface="Arial"/>
+        <a:buFont typeface="Arial" panose="020B0604020202020204"/>
         <a:buChar char="•"/>
         <a:defRPr sz="2400" kern="1200">
           <a:solidFill>
@@ -2904,7 +2877,7 @@
         <a:spcBef>
           <a:spcPct val="20000"/>
         </a:spcBef>
-        <a:buFont typeface="Arial"/>
+        <a:buFont typeface="Arial" panose="020B0604020202020204"/>
         <a:buChar char="–"/>
         <a:defRPr sz="2000" kern="1200">
           <a:solidFill>
@@ -2919,7 +2892,7 @@
         <a:spcBef>
           <a:spcPct val="20000"/>
         </a:spcBef>
-        <a:buFont typeface="Arial"/>
+        <a:buFont typeface="Arial" panose="020B0604020202020204"/>
         <a:buChar char="»"/>
         <a:defRPr sz="2000" kern="1200">
           <a:solidFill>
@@ -2934,7 +2907,7 @@
         <a:spcBef>
           <a:spcPct val="20000"/>
         </a:spcBef>
-        <a:buFont typeface="Arial"/>
+        <a:buFont typeface="Arial" panose="020B0604020202020204"/>
         <a:buChar char="•"/>
         <a:defRPr sz="2000" kern="1200">
           <a:solidFill>
@@ -2949,7 +2922,7 @@
         <a:spcBef>
           <a:spcPct val="20000"/>
         </a:spcBef>
-        <a:buFont typeface="Arial"/>
+        <a:buFont typeface="Arial" panose="020B0604020202020204"/>
         <a:buChar char="•"/>
         <a:defRPr sz="2000" kern="1200">
           <a:solidFill>
@@ -2964,7 +2937,7 @@
         <a:spcBef>
           <a:spcPct val="20000"/>
         </a:spcBef>
-        <a:buFont typeface="Arial"/>
+        <a:buFont typeface="Arial" panose="020B0604020202020204"/>
         <a:buChar char="•"/>
         <a:defRPr sz="2000" kern="1200">
           <a:solidFill>
@@ -2979,7 +2952,7 @@
         <a:spcBef>
           <a:spcPct val="20000"/>
         </a:spcBef>
-        <a:buFont typeface="Arial"/>
+        <a:buFont typeface="Arial" panose="020B0604020202020204"/>
         <a:buChar char="•"/>
         <a:defRPr sz="2000" kern="1200">
           <a:solidFill>
@@ -3091,7 +3064,7 @@
 </file>
 
 <file path=ppt/slides/slide1.xml><?xml version="1.0" encoding="utf-8"?>
-<p:sld xmlns:a="http://schemas.openxmlformats.org/drawingml/2006/main" xmlns:p="http://schemas.openxmlformats.org/presentationml/2006/main" xmlns:r="http://schemas.openxmlformats.org/officeDocument/2006/relationships">
+<p:sld xmlns:a="http://schemas.openxmlformats.org/drawingml/2006/main" xmlns:r="http://schemas.openxmlformats.org/officeDocument/2006/relationships" xmlns:p="http://schemas.openxmlformats.org/presentationml/2006/main">
   <p:cSld>
     <p:spTree>
       <p:nvGrpSpPr>
@@ -3138,11 +3111,6 @@
           <a:p>
             <a:r>
               <a:t>A Unified, Offline-First, Multi-Tiered AI Ecosystem</a:t>
-            </a:r>
-          </a:p>
-          <a:p>
-            <a:r>
-              <a:t>Master Pitch for HoD &amp; Research Review</a:t>
             </a:r>
           </a:p>
         </p:txBody>
@@ -3156,7 +3124,7 @@
 </file>
 
 <file path=ppt/slides/slide10.xml><?xml version="1.0" encoding="utf-8"?>
-<p:sld xmlns:a="http://schemas.openxmlformats.org/drawingml/2006/main" xmlns:p="http://schemas.openxmlformats.org/presentationml/2006/main" xmlns:r="http://schemas.openxmlformats.org/officeDocument/2006/relationships">
+<p:sld xmlns:a="http://schemas.openxmlformats.org/drawingml/2006/main" xmlns:r="http://schemas.openxmlformats.org/officeDocument/2006/relationships" xmlns:p="http://schemas.openxmlformats.org/presentationml/2006/main">
   <p:cSld>
     <p:spTree>
       <p:nvGrpSpPr>
@@ -3210,7 +3178,7 @@
           <a:p/>
           <a:p>
             <a:pPr>
-              <a:defRPr b="1" sz="2200"/>
+              <a:defRPr sz="2200" b="1"/>
             </a:pPr>
             <a:r>
               <a:t>Designed for NGOs and Government rollout with $0 recurring cloud costs.</a:t>
@@ -3259,7 +3227,7 @@
 </file>
 
 <file path=ppt/slides/slide11.xml><?xml version="1.0" encoding="utf-8"?>
-<p:sld xmlns:a="http://schemas.openxmlformats.org/drawingml/2006/main" xmlns:p="http://schemas.openxmlformats.org/presentationml/2006/main" xmlns:r="http://schemas.openxmlformats.org/officeDocument/2006/relationships">
+<p:sld xmlns:a="http://schemas.openxmlformats.org/drawingml/2006/main" xmlns:r="http://schemas.openxmlformats.org/officeDocument/2006/relationships" xmlns:p="http://schemas.openxmlformats.org/presentationml/2006/main">
   <p:cSld>
     <p:spTree>
       <p:nvGrpSpPr>
@@ -3313,7 +3281,7 @@
           <a:p/>
           <a:p>
             <a:pPr>
-              <a:defRPr b="1" sz="2200"/>
+              <a:defRPr sz="2200" b="1"/>
             </a:pPr>
             <a:r>
               <a:t>We analyzed 100+ recent IEEE/Springer papers to prove our novelty:</a:t>
@@ -3354,7 +3322,7 @@
 </file>
 
 <file path=ppt/slides/slide12.xml><?xml version="1.0" encoding="utf-8"?>
-<p:sld xmlns:a="http://schemas.openxmlformats.org/drawingml/2006/main" xmlns:p="http://schemas.openxmlformats.org/presentationml/2006/main" xmlns:r="http://schemas.openxmlformats.org/officeDocument/2006/relationships">
+<p:sld xmlns:a="http://schemas.openxmlformats.org/drawingml/2006/main" xmlns:r="http://schemas.openxmlformats.org/officeDocument/2006/relationships" xmlns:p="http://schemas.openxmlformats.org/presentationml/2006/main">
   <p:cSld>
     <p:spTree>
       <p:nvGrpSpPr>
@@ -3449,7 +3417,7 @@
 </file>
 
 <file path=ppt/slides/slide13.xml><?xml version="1.0" encoding="utf-8"?>
-<p:sld xmlns:a="http://schemas.openxmlformats.org/drawingml/2006/main" xmlns:p="http://schemas.openxmlformats.org/presentationml/2006/main" xmlns:r="http://schemas.openxmlformats.org/officeDocument/2006/relationships">
+<p:sld xmlns:a="http://schemas.openxmlformats.org/drawingml/2006/main" xmlns:r="http://schemas.openxmlformats.org/officeDocument/2006/relationships" xmlns:p="http://schemas.openxmlformats.org/presentationml/2006/main">
   <p:cSld>
     <p:spTree>
       <p:nvGrpSpPr>
@@ -3506,7 +3474,7 @@
               <a:spcBef>
                 <a:spcPts val="1400"/>
               </a:spcBef>
-              <a:defRPr b="1" sz="2200"/>
+              <a:defRPr sz="2200" b="1"/>
             </a:pPr>
             <a:r>
               <a:t>• It's not just an app; it's a completely decentralized agricultural ecosystem.</a:t>
@@ -3517,7 +3485,7 @@
               <a:spcBef>
                 <a:spcPts val="1400"/>
               </a:spcBef>
-              <a:defRPr b="1" sz="2200"/>
+              <a:defRPr sz="2200" b="1"/>
             </a:pPr>
             <a:r>
               <a:t>• It bridges the 'Integration Gap' by putting 9 advanced tools in one place.</a:t>
@@ -3528,7 +3496,7 @@
               <a:spcBef>
                 <a:spcPts val="1400"/>
               </a:spcBef>
-              <a:defRPr b="1" sz="2200"/>
+              <a:defRPr sz="2200" b="1"/>
             </a:pPr>
             <a:r>
               <a:t>• It respects the realities of rural India (low literacy, poor internet, high cost).</a:t>
@@ -3539,7 +3507,7 @@
               <a:spcBef>
                 <a:spcPts val="1400"/>
               </a:spcBef>
-              <a:defRPr b="1" sz="2200"/>
+              <a:defRPr sz="2200" b="1"/>
             </a:pPr>
             <a:r>
               <a:t>• It is fully documented, extensively researched, and ready for IEEE publication.</a:t>
@@ -3556,7 +3524,7 @@
 </file>
 
 <file path=ppt/slides/slide2.xml><?xml version="1.0" encoding="utf-8"?>
-<p:sld xmlns:a="http://schemas.openxmlformats.org/drawingml/2006/main" xmlns:p="http://schemas.openxmlformats.org/presentationml/2006/main" xmlns:r="http://schemas.openxmlformats.org/officeDocument/2006/relationships">
+<p:sld xmlns:a="http://schemas.openxmlformats.org/drawingml/2006/main" xmlns:r="http://schemas.openxmlformats.org/officeDocument/2006/relationships" xmlns:p="http://schemas.openxmlformats.org/presentationml/2006/main">
   <p:cSld>
     <p:spTree>
       <p:nvGrpSpPr>
@@ -3610,7 +3578,7 @@
           <a:p/>
           <a:p>
             <a:pPr>
-              <a:defRPr b="1" sz="2200"/>
+              <a:defRPr sz="2200" b="1"/>
             </a:pPr>
             <a:r>
               <a:t>Current State of Agri-Tech Research:</a:t>
@@ -3659,7 +3627,7 @@
 </file>
 
 <file path=ppt/slides/slide3.xml><?xml version="1.0" encoding="utf-8"?>
-<p:sld xmlns:a="http://schemas.openxmlformats.org/drawingml/2006/main" xmlns:p="http://schemas.openxmlformats.org/presentationml/2006/main" xmlns:r="http://schemas.openxmlformats.org/officeDocument/2006/relationships">
+<p:sld xmlns:a="http://schemas.openxmlformats.org/drawingml/2006/main" xmlns:r="http://schemas.openxmlformats.org/officeDocument/2006/relationships" xmlns:p="http://schemas.openxmlformats.org/presentationml/2006/main">
   <p:cSld>
     <p:spTree>
       <p:nvGrpSpPr>
@@ -3713,17 +3681,17 @@
           <a:p/>
           <a:p>
             <a:pPr>
-              <a:defRPr b="1" sz="2200"/>
+              <a:defRPr sz="2200" b="1"/>
             </a:pPr>
             <a:r>
               <a:t>KrushikaDhara solves the 'Integration Gap' by unifying 9 distinct, state-of-the-art agricultural modules into a single, offline-resilient super-app.</a:t>
             </a:r>
           </a:p>
           <a:p>
+            <a:pPr>
+              <a:defRPr sz="2000" b="1"/>
+            </a:pPr>
             <a:br/>
-            <a:pPr>
-              <a:defRPr b="1" sz="2000"/>
-            </a:pPr>
             <a:r>
               <a:t>Core Pillars of Uniqueness:</a:t>
             </a:r>
@@ -3771,7 +3739,7 @@
 </file>
 
 <file path=ppt/slides/slide4.xml><?xml version="1.0" encoding="utf-8"?>
-<p:sld xmlns:a="http://schemas.openxmlformats.org/drawingml/2006/main" xmlns:p="http://schemas.openxmlformats.org/presentationml/2006/main" xmlns:r="http://schemas.openxmlformats.org/officeDocument/2006/relationships">
+<p:sld xmlns:a="http://schemas.openxmlformats.org/drawingml/2006/main" xmlns:r="http://schemas.openxmlformats.org/officeDocument/2006/relationships" xmlns:p="http://schemas.openxmlformats.org/presentationml/2006/main">
   <p:cSld>
     <p:spTree>
       <p:nvGrpSpPr>
@@ -3825,7 +3793,7 @@
           <a:p/>
           <a:p>
             <a:pPr>
-              <a:defRPr b="1" sz="2200"/>
+              <a:defRPr sz="2200" b="1"/>
             </a:pPr>
             <a:r>
               <a:t>On-Device Inference:</a:t>
@@ -3866,7 +3834,7 @@
           <p:nvPr/>
         </p:nvPicPr>
         <p:blipFill>
-          <a:blip r:embed="rId2"/>
+          <a:blip r:embed="rId1"/>
           <a:stretch>
             <a:fillRect/>
           </a:stretch>
@@ -3890,7 +3858,7 @@
 </file>
 
 <file path=ppt/slides/slide5.xml><?xml version="1.0" encoding="utf-8"?>
-<p:sld xmlns:a="http://schemas.openxmlformats.org/drawingml/2006/main" xmlns:p="http://schemas.openxmlformats.org/presentationml/2006/main" xmlns:r="http://schemas.openxmlformats.org/officeDocument/2006/relationships">
+<p:sld xmlns:a="http://schemas.openxmlformats.org/drawingml/2006/main" xmlns:r="http://schemas.openxmlformats.org/officeDocument/2006/relationships" xmlns:p="http://schemas.openxmlformats.org/presentationml/2006/main">
   <p:cSld>
     <p:spTree>
       <p:nvGrpSpPr>
@@ -3944,7 +3912,7 @@
           <a:p/>
           <a:p>
             <a:pPr>
-              <a:defRPr b="1" sz="2200"/>
+              <a:defRPr sz="2200" b="1"/>
             </a:pPr>
             <a:r>
               <a:t>Aerial Data Fusion:</a:t>
@@ -3985,7 +3953,7 @@
           <p:nvPr/>
         </p:nvPicPr>
         <p:blipFill>
-          <a:blip r:embed="rId2"/>
+          <a:blip r:embed="rId1"/>
           <a:stretch>
             <a:fillRect/>
           </a:stretch>
@@ -4009,7 +3977,7 @@
 </file>
 
 <file path=ppt/slides/slide6.xml><?xml version="1.0" encoding="utf-8"?>
-<p:sld xmlns:a="http://schemas.openxmlformats.org/drawingml/2006/main" xmlns:p="http://schemas.openxmlformats.org/presentationml/2006/main" xmlns:r="http://schemas.openxmlformats.org/officeDocument/2006/relationships">
+<p:sld xmlns:a="http://schemas.openxmlformats.org/drawingml/2006/main" xmlns:r="http://schemas.openxmlformats.org/officeDocument/2006/relationships" xmlns:p="http://schemas.openxmlformats.org/presentationml/2006/main">
   <p:cSld>
     <p:spTree>
       <p:nvGrpSpPr>
@@ -4063,7 +4031,7 @@
           <a:p/>
           <a:p>
             <a:pPr>
-              <a:defRPr b="1" sz="2200"/>
+              <a:defRPr sz="2200" b="1"/>
             </a:pPr>
             <a:r>
               <a:t>The Rural Connectivity Fix:</a:t>
@@ -4112,7 +4080,7 @@
           <p:nvPr/>
         </p:nvPicPr>
         <p:blipFill>
-          <a:blip r:embed="rId2"/>
+          <a:blip r:embed="rId1"/>
           <a:stretch>
             <a:fillRect/>
           </a:stretch>
@@ -4136,7 +4104,7 @@
 </file>
 
 <file path=ppt/slides/slide7.xml><?xml version="1.0" encoding="utf-8"?>
-<p:sld xmlns:a="http://schemas.openxmlformats.org/drawingml/2006/main" xmlns:p="http://schemas.openxmlformats.org/presentationml/2006/main" xmlns:r="http://schemas.openxmlformats.org/officeDocument/2006/relationships">
+<p:sld xmlns:a="http://schemas.openxmlformats.org/drawingml/2006/main" xmlns:r="http://schemas.openxmlformats.org/officeDocument/2006/relationships" xmlns:p="http://schemas.openxmlformats.org/presentationml/2006/main">
   <p:cSld>
     <p:spTree>
       <p:nvGrpSpPr>
@@ -4190,7 +4158,7 @@
           <a:p/>
           <a:p>
             <a:pPr>
-              <a:defRPr b="1" sz="2200"/>
+              <a:defRPr sz="2200" b="1"/>
             </a:pPr>
             <a:r>
               <a:t>Breaking the Language Barrier:</a:t>
@@ -4205,10 +4173,10 @@
             </a:r>
           </a:p>
           <a:p>
+            <a:pPr>
+              <a:defRPr sz="2200" b="1"/>
+            </a:pPr>
             <a:br/>
-            <a:pPr>
-              <a:defRPr b="1" sz="2200"/>
-            </a:pPr>
             <a:r>
               <a:t>Hallucination-Free Architecture:</a:t>
             </a:r>
@@ -4240,7 +4208,7 @@
           <p:nvPr/>
         </p:nvPicPr>
         <p:blipFill>
-          <a:blip r:embed="rId2"/>
+          <a:blip r:embed="rId1"/>
           <a:stretch>
             <a:fillRect/>
           </a:stretch>
@@ -4264,7 +4232,7 @@
 </file>
 
 <file path=ppt/slides/slide8.xml><?xml version="1.0" encoding="utf-8"?>
-<p:sld xmlns:a="http://schemas.openxmlformats.org/drawingml/2006/main" xmlns:p="http://schemas.openxmlformats.org/presentationml/2006/main" xmlns:r="http://schemas.openxmlformats.org/officeDocument/2006/relationships">
+<p:sld xmlns:a="http://schemas.openxmlformats.org/drawingml/2006/main" xmlns:r="http://schemas.openxmlformats.org/officeDocument/2006/relationships" xmlns:p="http://schemas.openxmlformats.org/presentationml/2006/main">
   <p:cSld>
     <p:spTree>
       <p:nvGrpSpPr>
@@ -4318,7 +4286,7 @@
           <a:p/>
           <a:p>
             <a:pPr>
-              <a:defRPr b="1" sz="2200"/>
+              <a:defRPr sz="2200" b="1"/>
             </a:pPr>
             <a:r>
               <a:t>Unified Farm Security:</a:t>
@@ -4333,10 +4301,10 @@
             </a:r>
           </a:p>
           <a:p>
+            <a:pPr>
+              <a:defRPr sz="2200" b="1"/>
+            </a:pPr>
             <a:br/>
-            <a:pPr>
-              <a:defRPr b="1" sz="2200"/>
-            </a:pPr>
             <a:r>
               <a:t>Multi-Sensor Fusion:</a:t>
             </a:r>
@@ -4350,10 +4318,10 @@
             </a:r>
           </a:p>
           <a:p>
+            <a:pPr>
+              <a:defRPr sz="2200" b="1"/>
+            </a:pPr>
             <a:br/>
-            <a:pPr>
-              <a:defRPr b="1" sz="2200"/>
-            </a:pPr>
             <a:r>
               <a:t>TinyML Edge Processing:</a:t>
             </a:r>
@@ -4377,7 +4345,7 @@
           <p:nvPr/>
         </p:nvPicPr>
         <p:blipFill>
-          <a:blip r:embed="rId2"/>
+          <a:blip r:embed="rId1"/>
           <a:stretch>
             <a:fillRect/>
           </a:stretch>
@@ -4401,7 +4369,7 @@
 </file>
 
 <file path=ppt/slides/slide9.xml><?xml version="1.0" encoding="utf-8"?>
-<p:sld xmlns:a="http://schemas.openxmlformats.org/drawingml/2006/main" xmlns:p="http://schemas.openxmlformats.org/presentationml/2006/main" xmlns:r="http://schemas.openxmlformats.org/officeDocument/2006/relationships">
+<p:sld xmlns:a="http://schemas.openxmlformats.org/drawingml/2006/main" xmlns:r="http://schemas.openxmlformats.org/officeDocument/2006/relationships" xmlns:p="http://schemas.openxmlformats.org/presentationml/2006/main">
   <p:cSld>
     <p:spTree>
       <p:nvGrpSpPr>
@@ -4458,7 +4426,7 @@
               <a:spcBef>
                 <a:spcPts val="1400"/>
               </a:spcBef>
-              <a:defRPr b="1" sz="2000"/>
+              <a:defRPr sz="2000" b="1"/>
             </a:pPr>
             <a:r>
               <a:t>6. Crop Advisory &amp; Calendar: Personalized timelines based on planting dates.</a:t>
@@ -4469,7 +4437,7 @@
               <a:spcBef>
                 <a:spcPts val="1400"/>
               </a:spcBef>
-              <a:defRPr b="1" sz="2000"/>
+              <a:defRPr sz="2000" b="1"/>
             </a:pPr>
             <a:r>
               <a:t>7. Market Prices &amp; Trends: Live APMC mandi prices using Govt APIs.</a:t>
@@ -4480,7 +4448,7 @@
               <a:spcBef>
                 <a:spcPts val="1400"/>
               </a:spcBef>
-              <a:defRPr b="1" sz="2000"/>
+              <a:defRPr sz="2000" b="1"/>
             </a:pPr>
             <a:r>
               <a:t>8. Precision Weather Forecasting: Hyper-local weather data to schedule irrigation.</a:t>
@@ -4491,17 +4459,17 @@
               <a:spcBef>
                 <a:spcPts val="1400"/>
               </a:spcBef>
-              <a:defRPr b="1" sz="2000"/>
+              <a:defRPr sz="2000" b="1"/>
             </a:pPr>
             <a:r>
               <a:t>9. Secure Authentication: Supabase/Firebase integrated secure user management.</a:t>
             </a:r>
           </a:p>
           <a:p>
+            <a:pPr>
+              <a:defRPr sz="2200" b="1" i="1"/>
+            </a:pPr>
             <a:br/>
-            <a:pPr>
-              <a:defRPr b="1" i="1" sz="2200"/>
-            </a:pPr>
             <a:r>
               <a:t>Result: The farmer never has to leave the KrushikaDhara app for any agricultural need.</a:t>
             </a:r>
@@ -4832,6 +4800,10 @@
       </a:style>
     </a:lnDef>
   </a:objectDefaults>
-  <a:extraClrSchemeLst/>
+  <a:extLst>
+    <a:ext uri="{05A4C25C-085E-4340-85A3-A5531E510DB2}">
+      <thm15:themeFamily xmlns:thm15="http://schemas.microsoft.com/office/thememl/2012/main" name="Office Theme" id="{62F939B6-93AF-4DB8-9C6B-D6C7DFDC589F}" vid="{4A3C46E8-61CC-4603-A589-7422A47A8E4A}"/>
+    </a:ext>
+  </a:extLst>
 </a:theme>
 </file>
</xml_diff>